<commit_message>
Add solution artifacts and session outputs
</commit_message>
<xml_diff>
--- a/baby_milestones_9_12_months/baby_milestones_9_12_months.pptx
+++ b/baby_milestones_9_12_months/baby_milestones_9_12_months.pptx
@@ -2326,8 +2326,8 @@
         </p:blipFill>
         <p:spPr>
           <a:xfrm>
-            <a:off x="720344" y="1847088"/>
-            <a:ext cx="3634232" cy="4005072"/>
+            <a:off x="548640" y="2016681"/>
+            <a:ext cx="4160520" cy="3510439"/>
           </a:xfrm>
           <a:prstGeom prst="rect">
             <a:avLst/>

</xml_diff>